<commit_message>
Proofread swe-bench-pro slides page by page with Gemini
</commit_message>
<xml_diff>
--- a/slides/datasets-in-10-minutes-swe-bench-pro.pptx
+++ b/slides/datasets-in-10-minutes-swe-bench-pro.pptx
@@ -7855,7 +7855,7 @@
                 <a:ea typeface="Noto Sans CJK JP"/>
                 <a:cs typeface="Noto Sans"/>
               </a:rPr>
-              <a:t>存在しないフォルダーを指定したら、保存を始めずに[[error:invalid-path]]を返す。</a:t>
+              <a:t>存在しないフォルダーを指定した場合は、保存を開始せずに[[error:invalid-path]]を返す。</a:t>
             </a:r>
           </a:p>
         </p:txBody>
@@ -8071,7 +8071,7 @@
                 <a:ea typeface="Noto Sans CJK JP"/>
                 <a:cs typeface="Noto Sans"/>
               </a:rPr>
-              <a:t>存在しない保存先を拒否する1件と、既存のアップロード・削除・取得など34件のテストを通す。</a:t>
+              <a:t>存在しない保存先を拒否する1件と、既存のアップロード・削除・取得など34件のテストが通過すること。</a:t>
             </a:r>
           </a:p>
         </p:txBody>
@@ -10129,7 +10129,7 @@
                 <a:ea typeface="Noto Sans CJK JP"/>
                 <a:cs typeface="Noto Sans"/>
               </a:rPr>
-              <a:t>必要なテストがすべて通れば、課題の合格</a:t>
+              <a:t>必要なテストがすべて通れば課題合格</a:t>
             </a:r>
           </a:p>
         </p:txBody>
@@ -13642,7 +13642,7 @@
                 <a:ea typeface="Noto Sans CJK JP"/>
                 <a:cs typeface="Noto Sans"/>
               </a:rPr>
-              <a:t>公開前に、参照修正と空の修正を全件実行した</a:t>
+              <a:t>公開前に、参照パッチと空パッチを全件実行した</a:t>
             </a:r>
           </a:p>
         </p:txBody>
@@ -14372,23 +14372,23 @@
                 <a:spcPct val="110000"/>
               </a:lnSpc>
               <a:buNone/>
-              <a:defRPr sz="2800" b="0">
-                <a:solidFill>
-                  <a:srgbClr val="303437"/>
-                </a:solidFill>
-                <a:latin typeface="Noto Sans"/>
-              </a:defRPr>
-            </a:pPr>
-            <a:r>
-              <a:rPr sz="2800" b="1" lang="ja-JP" altLang="en-US">
-                <a:solidFill>
-                  <a:srgbClr val="303437"/>
-                </a:solidFill>
-                <a:latin typeface="Noto Sans"/>
-                <a:ea typeface="Noto Sans CJK JP"/>
-                <a:cs typeface="Noto Sans"/>
-              </a:rPr>
-              <a:t>HARD-51は、難しい51課題を抜き出す</a:t>
+              <a:defRPr sz="2500" b="0">
+                <a:solidFill>
+                  <a:srgbClr val="303437"/>
+                </a:solidFill>
+                <a:latin typeface="Noto Sans"/>
+              </a:defRPr>
+            </a:pPr>
+            <a:r>
+              <a:rPr sz="2500" b="1" lang="ja-JP" altLang="en-US">
+                <a:solidFill>
+                  <a:srgbClr val="303437"/>
+                </a:solidFill>
+                <a:latin typeface="Noto Sans"/>
+                <a:ea typeface="Noto Sans CJK JP"/>
+                <a:cs typeface="Noto Sans"/>
+              </a:rPr>
+              <a:t>HARD-51は、難しい51課題を抜き出したサブセット</a:t>
             </a:r>
           </a:p>
         </p:txBody>
@@ -14900,7 +14900,7 @@
                 <a:ea typeface="Noto Sans CJK JP"/>
                 <a:cs typeface="Noto Sans"/>
               </a:rPr>
-              <a:t>差分のうちテスト関連の変更を採点用のテストパッチにし、それ以外を参照修正のgold patchとして分ける。</a:t>
+              <a:t>差分のうちテスト関連の変更を採点用のテストパッチとし、それ以外を参照修正のgold patchとする。</a:t>
             </a:r>
           </a:p>
           <a:p>
@@ -14930,7 +14930,7 @@
                 <a:ea typeface="Noto Sans CJK JP"/>
                 <a:cs typeface="Noto Sans"/>
               </a:rPr>
-              <a:t>公開・留保集合ではコピーレフトのプロジェクトを使い、商用集合では提携したスタートアップの非公開コードを用いた。</a:t>
+              <a:t>公開・留保集合ではコピーレフトのプロジェクトを使い、商用集合では提携したスタートアップの非公開コードを用いる。</a:t>
             </a:r>
           </a:p>
         </p:txBody>
@@ -15762,7 +15762,7 @@
                 <a:ea typeface="Noto Sans CJK JP"/>
                 <a:cs typeface="Noto Sans"/>
               </a:rPr>
-              <a:t>当初の全1,865課題は、3集合からなる</a:t>
+              <a:t>当初の全1,865課題は、3つの集合からなる</a:t>
             </a:r>
           </a:p>
         </p:txBody>
@@ -16746,7 +16746,7 @@
                 <a:ea typeface="Noto Sans CJK JP"/>
                 <a:cs typeface="Noto Sans"/>
               </a:rPr>
-              <a:t>2025年論文の構成。集合間ではリポジトリを分ける。</a:t>
+              <a:t>2025年論文の構成。集合間でリポジトリは重複しない。</a:t>
             </a:r>
           </a:p>
           <a:p>
@@ -16931,7 +16931,7 @@
                 <a:ea typeface="Noto Sans CJK JP"/>
                 <a:cs typeface="Noto Sans"/>
               </a:rPr>
-              <a:t>バージョン2では、89課題を除外した</a:t>
+              <a:t>バージョン2では、89件の課題を除外した</a:t>
             </a:r>
           </a:p>
         </p:txBody>
@@ -17591,7 +17591,7 @@
                 <a:ea typeface="Noto Sans CJK JP"/>
                 <a:cs typeface="Noto Sans"/>
               </a:rPr>
-              <a:t>要求文と採点条件の対応を確かめ、各課題の修正前コミットは維持。</a:t>
+              <a:t>要求文と採点条件の対応を確認し、各課題の修正前コミットは維持した。</a:t>
             </a:r>
           </a:p>
         </p:txBody>
@@ -19301,7 +19301,7 @@
                 <a:ea typeface="Noto Sans CJK JP"/>
                 <a:cs typeface="Noto Sans"/>
               </a:rPr>
-              <a:t>公開バージョン2は642課題。課題文と採点環境を改めて検証し、難しい51課題を選ぶHARD-51も提供する。</a:t>
+              <a:t>公開バージョン2は642課題。課題文と採点環境を改めて検証し、難しい51課題を選んだHARD-51も提供する。</a:t>
             </a:r>
           </a:p>
         </p:txBody>
@@ -20615,7 +20615,7 @@
                 <a:ea typeface="Noto Sans CJK JP"/>
                 <a:cs typeface="Noto Sans"/>
               </a:rPr>
-              <a:t>def.collectionのようにPythonの予約語を含む名前は、名前の検証結果をFalseにする。</a:t>
+              <a:t>def.collectionのようにPythonの予約語を含む名前は、検証結果をFalseにする。</a:t>
             </a:r>
           </a:p>
         </p:txBody>
@@ -22823,7 +22823,7 @@
                 <a:ea typeface="Noto Sans CJK JP"/>
                 <a:cs typeface="Noto Sans"/>
               </a:rPr>
-              <a:t>TestLoadで、設定が読み込まれることと、許されない組み合わせが指定のエラーメッセージになることを確かめる。</a:t>
+              <a:t>TestLoadで、設定が読み込まれることと、許されない組み合わせで指定のエラーメッセージが返されることを確かめる。</a:t>
             </a:r>
           </a:p>
         </p:txBody>
@@ -24021,7 +24021,7 @@
                 <a:ea typeface="Noto Sans CJK JP"/>
                 <a:cs typeface="Noto Sans"/>
               </a:rPr>
-              <a:t>Element Webのメッセージ入力欄。未入力時の案内文を、リッチテキストとプレーンテキストの両方で切り替える。</a:t>
+              <a:t>Element Webのメッセージ入力欄。未入力時の案内文の表示を、リッチテキストとプレーンテキストの両方で切り替える。</a:t>
             </a:r>
           </a:p>
         </p:txBody>
@@ -25640,7 +25640,7 @@
                 <a:ea typeface="Noto Sans CJK JP"/>
                 <a:cs typeface="Noto Sans"/>
               </a:rPr>
-              <a:t>グループの詳細画面で、複数件の表示と、メールアドレスが1件だけの表示を2テストで確認する。</a:t>
+              <a:t>グループの詳細画面で、複数件の表示と、メールアドレスが1件だけの表示を2つのテストで確認する。</a:t>
             </a:r>
           </a:p>
         </p:txBody>
@@ -28664,7 +28664,7 @@
                 <a:ea typeface="Noto Sans CJK JP"/>
                 <a:cs typeface="Noto Sans"/>
               </a:rPr>
-              <a:t>投稿IDから所属カテゴリを調べる。管理者以外には、そのカテゴリのtopics:read権限があることを確認する。</a:t>
+              <a:t>投稿IDから所属カテゴリを調べる。管理者以外の場合は、そのカテゴリのtopics:read権限があることを確認する。</a:t>
             </a:r>
           </a:p>
         </p:txBody>
@@ -29875,23 +29875,23 @@
                 <a:spcPct val="110000"/>
               </a:lnSpc>
               <a:buNone/>
-              <a:defRPr sz="2800" b="0">
-                <a:solidFill>
-                  <a:srgbClr val="303437"/>
-                </a:solidFill>
-                <a:latin typeface="Noto Sans"/>
-              </a:defRPr>
-            </a:pPr>
-            <a:r>
-              <a:rPr sz="2800" b="1" lang="ja-JP" altLang="en-US">
-                <a:solidFill>
-                  <a:srgbClr val="303437"/>
-                </a:solidFill>
-                <a:latin typeface="Noto Sans"/>
-                <a:ea typeface="Noto Sans CJK JP"/>
-                <a:cs typeface="Noto Sans"/>
-              </a:rPr>
-              <a:t>公開バージョン2のリポジトリ別の課題数</a:t>
+              <a:defRPr sz="2500" b="0">
+                <a:solidFill>
+                  <a:srgbClr val="303437"/>
+                </a:solidFill>
+                <a:latin typeface="Noto Sans"/>
+              </a:defRPr>
+            </a:pPr>
+            <a:r>
+              <a:rPr sz="2500" b="1" lang="ja-JP" altLang="en-US">
+                <a:solidFill>
+                  <a:srgbClr val="303437"/>
+                </a:solidFill>
+                <a:latin typeface="Noto Sans"/>
+                <a:ea typeface="Noto Sans CJK JP"/>
+                <a:cs typeface="Noto Sans"/>
+              </a:rPr>
+              <a:t>公開バージョン2のリポジトリ別の課題数（1/2）</a:t>
             </a:r>
           </a:p>
         </p:txBody>
@@ -30893,23 +30893,23 @@
                 <a:spcPct val="110000"/>
               </a:lnSpc>
               <a:buNone/>
-              <a:defRPr sz="2800" b="0">
-                <a:solidFill>
-                  <a:srgbClr val="303437"/>
-                </a:solidFill>
-                <a:latin typeface="Noto Sans"/>
-              </a:defRPr>
-            </a:pPr>
-            <a:r>
-              <a:rPr sz="2800" b="1" lang="ja-JP" altLang="en-US">
-                <a:solidFill>
-                  <a:srgbClr val="303437"/>
-                </a:solidFill>
-                <a:latin typeface="Noto Sans"/>
-                <a:ea typeface="Noto Sans CJK JP"/>
-                <a:cs typeface="Noto Sans"/>
-              </a:rPr>
-              <a:t>公開バージョン2のリポジトリ別の課題数</a:t>
+              <a:defRPr sz="2500" b="0">
+                <a:solidFill>
+                  <a:srgbClr val="303437"/>
+                </a:solidFill>
+                <a:latin typeface="Noto Sans"/>
+              </a:defRPr>
+            </a:pPr>
+            <a:r>
+              <a:rPr sz="2500" b="1" lang="ja-JP" altLang="en-US">
+                <a:solidFill>
+                  <a:srgbClr val="303437"/>
+                </a:solidFill>
+                <a:latin typeface="Noto Sans"/>
+                <a:ea typeface="Noto Sans CJK JP"/>
+                <a:cs typeface="Noto Sans"/>
+              </a:rPr>
+              <a:t>公開バージョン2のリポジトリ別の課題数（2/2）</a:t>
             </a:r>
           </a:p>
         </p:txBody>
@@ -31908,7 +31908,7 @@
                 <a:ea typeface="Noto Sans CJK JP"/>
                 <a:cs typeface="Noto Sans"/>
               </a:rPr>
-              <a:t>Proでは、業務アプリや開発ツールなどの対象を広げ、長い修正や複数ファイルの変更を扱う。問題文に人手で要件と必要なインターフェースを補う。</a:t>
+              <a:t>Proでは、業務アプリや開発ツールなどへ対象を広げ、長い修正や複数ファイルの変更を扱う。問題文に人手で要件と必要なインターフェースを補う。</a:t>
             </a:r>
           </a:p>
           <a:p>
@@ -32884,7 +32884,7 @@
                 <a:ea typeface="Noto Sans CJK JP"/>
                 <a:cs typeface="Noto Sans"/>
               </a:rPr>
-              <a:t>Scale AIが、課題と実行環境を公開した</a:t>
+              <a:t>Scale AIが課題と実行環境を公開した</a:t>
             </a:r>
           </a:p>
         </p:txBody>
@@ -32937,7 +32937,7 @@
                 <a:ea typeface="Noto Sans CJK JP"/>
                 <a:cs typeface="Noto Sans"/>
               </a:rPr>
-              <a:t>論文の共同第一著者はXiang DengとJeff Da。Scale AIの研究として、ソフトウェア開発エージェントの実務的な評価を目的に制作した。</a:t>
+              <a:t>論文の共同第一著者はXiang DengとJeff Da。Scale AIの研究として、ソフトウェア開発エージェントの実務的な評価を目的に開発された。</a:t>
             </a:r>
           </a:p>
           <a:p>
@@ -32997,7 +32997,7 @@
                 <a:ea typeface="Noto Sans CJK JP"/>
                 <a:cs typeface="Noto Sans"/>
               </a:rPr>
-              <a:t>データのバージョン2は2026年9月22日に公開した別の更新。課題文・テスト・コンテナ・評価手順の修正を含む。</a:t>
+              <a:t>データのバージョン2は2026年9月22日に公開された別の更新。課題文・テスト・コンテナ・評価手順の修正を含む。</a:t>
             </a:r>
           </a:p>
         </p:txBody>
@@ -34441,7 +34441,7 @@
                 <a:ea typeface="Noto Sans CJK JP"/>
                 <a:cs typeface="Noto Sans"/>
               </a:rPr>
-              <a:t>本資料の実例は、公開バージョン2から選ぶ</a:t>
+              <a:t>本資料の実例は公開バージョン2から選定</a:t>
             </a:r>
           </a:p>
         </p:txBody>
@@ -34875,7 +34875,7 @@
                           <a:ea typeface="Noto Sans CJK JP"/>
                           <a:cs typeface="Noto Sans"/>
                         </a:rPr>
-                        <a:t>検証を改めたバージョン2</a:t>
+                        <a:t>検証を見直したバージョン2</a:t>
                       </a:r>
                     </a:p>
                   </a:txBody>
@@ -35212,7 +35212,7 @@
                 <a:ea typeface="Noto Sans CJK JP"/>
                 <a:cs typeface="Noto Sans"/>
               </a:rPr>
-              <a:t>実例はバージョン2から本編3件・Appendix10件を選んだ。</a:t>
+              <a:t>実例はバージョン2から本編3件・Appendix 10件を選定した。</a:t>
             </a:r>
           </a:p>
           <a:p>
@@ -35243,7 +35243,7 @@
                 <a:ea typeface="Noto Sans CJK JP"/>
                 <a:cs typeface="Noto Sans"/>
               </a:rPr>
-              <a:t>HARD-51は難しい課題を選んだサブセット。</a:t>
+              <a:t>HARD-51は難度の高い課題を抽出したサブセット。</a:t>
             </a:r>
           </a:p>
         </p:txBody>

</xml_diff>